<commit_message>
Units: refresh 1, split old unit 4 into units 4+5, hide units 3-5
- 01 Slides.pptx updated (course-evaluation slide edits by Jorge).
- Old 15-slide unit 4 deck split by Jorge into 04.pptx ("Financial Analysis",
  3 slides) and 05.pptx ("Profitability Analysis", 13 slides). Added unit5 to
  extract_pptx.py and to ORDER.
- overrides.json: the former unit4 fixes (Talent Hackers / Example labels /
  Catenon caption) move to unit5 unchanged — the slide order matches. New unit4
  gets only its divider-title fix.
- overrides.json _config.hidden = [unit3, unit4, unit5]: hidden units get no
  index row and no nav, but still build and stay reachable by direct
  #/unitN/1 link for previewing. Empty the list to publish.
- Masthead copy no longer says "four units".

CI re-extracts deck_data.json from the changed decks on push.

Co-Authored-By: Claude Sonnet 5 <noreply@anthropic.com>
</commit_message>
<xml_diff>
--- a/source-pptx/01 Slides.pptx
+++ b/source-pptx/01 Slides.pptx
@@ -135,857 +135,22 @@
   <pc:docChgLst>
     <pc:chgData name="JORGE GALLUD CANO" userId="aa07a950-3061-465d-9845-1f16ea714d1e" providerId="ADAL" clId="{652E886E-EB52-40C6-999B-D6033CDA24D2}"/>
     <pc:docChg chg="modSld">
-      <pc:chgData name="JORGE GALLUD CANO" userId="aa07a950-3061-465d-9845-1f16ea714d1e" providerId="ADAL" clId="{652E886E-EB52-40C6-999B-D6033CDA24D2}" dt="2025-09-11T07:09:16.605" v="7" actId="20577"/>
+      <pc:chgData name="JORGE GALLUD CANO" userId="aa07a950-3061-465d-9845-1f16ea714d1e" providerId="ADAL" clId="{652E886E-EB52-40C6-999B-D6033CDA24D2}" dt="2026-09-09T08:53:00.903" v="17" actId="20577"/>
       <pc:docMkLst>
         <pc:docMk/>
       </pc:docMkLst>
       <pc:sldChg chg="modSp mod">
-        <pc:chgData name="JORGE GALLUD CANO" userId="aa07a950-3061-465d-9845-1f16ea714d1e" providerId="ADAL" clId="{652E886E-EB52-40C6-999B-D6033CDA24D2}" dt="2025-09-11T07:09:16.605" v="7" actId="20577"/>
-        <pc:sldMkLst>
-          <pc:docMk/>
-          <pc:sldMk cId="2604605080" sldId="528"/>
-        </pc:sldMkLst>
-        <pc:spChg chg="mod">
-          <ac:chgData name="JORGE GALLUD CANO" userId="aa07a950-3061-465d-9845-1f16ea714d1e" providerId="ADAL" clId="{652E886E-EB52-40C6-999B-D6033CDA24D2}" dt="2025-09-11T07:09:16.605" v="7" actId="20577"/>
-          <ac:spMkLst>
-            <pc:docMk/>
-            <pc:sldMk cId="2604605080" sldId="528"/>
-            <ac:spMk id="6" creationId="{211D8BE8-5AF5-00EB-B4B4-EA295A23E1DE}"/>
-          </ac:spMkLst>
-        </pc:spChg>
-      </pc:sldChg>
-    </pc:docChg>
-  </pc:docChgLst>
-  <pc:docChgLst>
-    <pc:chgData name="JORGE GALLUD CANO" userId="aa07a950-3061-465d-9845-1f16ea714d1e" providerId="ADAL" clId="{D5F518D7-5D08-48A0-AE37-FAC94EDFC64E}"/>
-    <pc:docChg chg="modSld">
-      <pc:chgData name="JORGE GALLUD CANO" userId="aa07a950-3061-465d-9845-1f16ea714d1e" providerId="ADAL" clId="{D5F518D7-5D08-48A0-AE37-FAC94EDFC64E}" dt="2025-09-14T14:33:16.654" v="23" actId="20577"/>
-      <pc:docMkLst>
-        <pc:docMk/>
-      </pc:docMkLst>
-      <pc:sldChg chg="modSp mod">
-        <pc:chgData name="JORGE GALLUD CANO" userId="aa07a950-3061-465d-9845-1f16ea714d1e" providerId="ADAL" clId="{D5F518D7-5D08-48A0-AE37-FAC94EDFC64E}" dt="2025-09-14T14:33:16.654" v="23" actId="20577"/>
-        <pc:sldMkLst>
-          <pc:docMk/>
-          <pc:sldMk cId="3017756465" sldId="278"/>
-        </pc:sldMkLst>
-        <pc:spChg chg="mod">
-          <ac:chgData name="JORGE GALLUD CANO" userId="aa07a950-3061-465d-9845-1f16ea714d1e" providerId="ADAL" clId="{D5F518D7-5D08-48A0-AE37-FAC94EDFC64E}" dt="2025-09-14T14:33:16.654" v="23" actId="20577"/>
-          <ac:spMkLst>
-            <pc:docMk/>
-            <pc:sldMk cId="3017756465" sldId="278"/>
-            <ac:spMk id="3" creationId="{00000000-0000-0000-0000-000000000000}"/>
-          </ac:spMkLst>
-        </pc:spChg>
-      </pc:sldChg>
-    </pc:docChg>
-  </pc:docChgLst>
-  <pc:docChgLst>
-    <pc:chgData name="JORGE GALLUD CANO" userId="aa07a950-3061-465d-9845-1f16ea714d1e" providerId="ADAL" clId="{40EA3D5A-36C4-48EA-916B-CE535004CE0B}"/>
-    <pc:docChg chg="undo custSel addSld delSld modSld">
-      <pc:chgData name="JORGE GALLUD CANO" userId="aa07a950-3061-465d-9845-1f16ea714d1e" providerId="ADAL" clId="{40EA3D5A-36C4-48EA-916B-CE535004CE0B}" dt="2025-08-23T10:55:58.152" v="601" actId="20577"/>
-      <pc:docMkLst>
-        <pc:docMk/>
-      </pc:docMkLst>
-      <pc:sldChg chg="modSp mod">
-        <pc:chgData name="JORGE GALLUD CANO" userId="aa07a950-3061-465d-9845-1f16ea714d1e" providerId="ADAL" clId="{40EA3D5A-36C4-48EA-916B-CE535004CE0B}" dt="2025-08-23T09:51:11.533" v="177" actId="20577"/>
+        <pc:chgData name="JORGE GALLUD CANO" userId="aa07a950-3061-465d-9845-1f16ea714d1e" providerId="ADAL" clId="{652E886E-EB52-40C6-999B-D6033CDA24D2}" dt="2026-09-09T08:53:00.903" v="17" actId="20577"/>
         <pc:sldMkLst>
           <pc:docMk/>
           <pc:sldMk cId="178495425" sldId="257"/>
         </pc:sldMkLst>
         <pc:spChg chg="mod">
-          <ac:chgData name="JORGE GALLUD CANO" userId="aa07a950-3061-465d-9845-1f16ea714d1e" providerId="ADAL" clId="{40EA3D5A-36C4-48EA-916B-CE535004CE0B}" dt="2025-08-23T09:51:11.533" v="177" actId="20577"/>
-          <ac:spMkLst>
-            <pc:docMk/>
-            <pc:sldMk cId="178495425" sldId="257"/>
-            <ac:spMk id="2" creationId="{00000000-0000-0000-0000-000000000000}"/>
-          </ac:spMkLst>
-        </pc:spChg>
-        <pc:spChg chg="mod">
-          <ac:chgData name="JORGE GALLUD CANO" userId="aa07a950-3061-465d-9845-1f16ea714d1e" providerId="ADAL" clId="{40EA3D5A-36C4-48EA-916B-CE535004CE0B}" dt="2025-08-23T09:50:54.138" v="167"/>
+          <ac:chgData name="JORGE GALLUD CANO" userId="aa07a950-3061-465d-9845-1f16ea714d1e" providerId="ADAL" clId="{652E886E-EB52-40C6-999B-D6033CDA24D2}" dt="2026-09-09T08:53:00.903" v="17" actId="20577"/>
           <ac:spMkLst>
             <pc:docMk/>
             <pc:sldMk cId="178495425" sldId="257"/>
             <ac:spMk id="3" creationId="{00000000-0000-0000-0000-000000000000}"/>
-          </ac:spMkLst>
-        </pc:spChg>
-      </pc:sldChg>
-      <pc:sldChg chg="modSp mod">
-        <pc:chgData name="JORGE GALLUD CANO" userId="aa07a950-3061-465d-9845-1f16ea714d1e" providerId="ADAL" clId="{40EA3D5A-36C4-48EA-916B-CE535004CE0B}" dt="2025-08-23T09:51:18.201" v="181" actId="20577"/>
-        <pc:sldMkLst>
-          <pc:docMk/>
-          <pc:sldMk cId="1246209980" sldId="258"/>
-        </pc:sldMkLst>
-        <pc:spChg chg="mod">
-          <ac:chgData name="JORGE GALLUD CANO" userId="aa07a950-3061-465d-9845-1f16ea714d1e" providerId="ADAL" clId="{40EA3D5A-36C4-48EA-916B-CE535004CE0B}" dt="2025-08-23T09:51:18.201" v="181" actId="20577"/>
-          <ac:spMkLst>
-            <pc:docMk/>
-            <pc:sldMk cId="1246209980" sldId="258"/>
-            <ac:spMk id="17" creationId="{00000000-0000-0000-0000-000000000000}"/>
-          </ac:spMkLst>
-        </pc:spChg>
-      </pc:sldChg>
-      <pc:sldChg chg="add del">
-        <pc:chgData name="JORGE GALLUD CANO" userId="aa07a950-3061-465d-9845-1f16ea714d1e" providerId="ADAL" clId="{40EA3D5A-36C4-48EA-916B-CE535004CE0B}" dt="2025-08-23T09:31:01.412" v="9" actId="47"/>
-        <pc:sldMkLst>
-          <pc:docMk/>
-          <pc:sldMk cId="1894586624" sldId="259"/>
-        </pc:sldMkLst>
-      </pc:sldChg>
-      <pc:sldChg chg="add del">
-        <pc:chgData name="JORGE GALLUD CANO" userId="aa07a950-3061-465d-9845-1f16ea714d1e" providerId="ADAL" clId="{40EA3D5A-36C4-48EA-916B-CE535004CE0B}" dt="2025-08-23T09:30:54.777" v="7" actId="47"/>
-        <pc:sldMkLst>
-          <pc:docMk/>
-          <pc:sldMk cId="3087793293" sldId="260"/>
-        </pc:sldMkLst>
-      </pc:sldChg>
-      <pc:sldChg chg="add del">
-        <pc:chgData name="JORGE GALLUD CANO" userId="aa07a950-3061-465d-9845-1f16ea714d1e" providerId="ADAL" clId="{40EA3D5A-36C4-48EA-916B-CE535004CE0B}" dt="2025-08-23T09:30:54.777" v="7" actId="47"/>
-        <pc:sldMkLst>
-          <pc:docMk/>
-          <pc:sldMk cId="3150193090" sldId="261"/>
-        </pc:sldMkLst>
-      </pc:sldChg>
-      <pc:sldChg chg="add del">
-        <pc:chgData name="JORGE GALLUD CANO" userId="aa07a950-3061-465d-9845-1f16ea714d1e" providerId="ADAL" clId="{40EA3D5A-36C4-48EA-916B-CE535004CE0B}" dt="2025-08-23T09:30:54.777" v="7" actId="47"/>
-        <pc:sldMkLst>
-          <pc:docMk/>
-          <pc:sldMk cId="594737123" sldId="262"/>
-        </pc:sldMkLst>
-      </pc:sldChg>
-      <pc:sldChg chg="add del">
-        <pc:chgData name="JORGE GALLUD CANO" userId="aa07a950-3061-465d-9845-1f16ea714d1e" providerId="ADAL" clId="{40EA3D5A-36C4-48EA-916B-CE535004CE0B}" dt="2025-08-23T09:30:54.777" v="7" actId="47"/>
-        <pc:sldMkLst>
-          <pc:docMk/>
-          <pc:sldMk cId="579264008" sldId="263"/>
-        </pc:sldMkLst>
-      </pc:sldChg>
-      <pc:sldChg chg="add del">
-        <pc:chgData name="JORGE GALLUD CANO" userId="aa07a950-3061-465d-9845-1f16ea714d1e" providerId="ADAL" clId="{40EA3D5A-36C4-48EA-916B-CE535004CE0B}" dt="2025-08-23T09:30:54.777" v="7" actId="47"/>
-        <pc:sldMkLst>
-          <pc:docMk/>
-          <pc:sldMk cId="3467514994" sldId="264"/>
-        </pc:sldMkLst>
-      </pc:sldChg>
-      <pc:sldChg chg="add del">
-        <pc:chgData name="JORGE GALLUD CANO" userId="aa07a950-3061-465d-9845-1f16ea714d1e" providerId="ADAL" clId="{40EA3D5A-36C4-48EA-916B-CE535004CE0B}" dt="2025-08-23T09:30:54.777" v="7" actId="47"/>
-        <pc:sldMkLst>
-          <pc:docMk/>
-          <pc:sldMk cId="2631823192" sldId="265"/>
-        </pc:sldMkLst>
-      </pc:sldChg>
-      <pc:sldChg chg="add del">
-        <pc:chgData name="JORGE GALLUD CANO" userId="aa07a950-3061-465d-9845-1f16ea714d1e" providerId="ADAL" clId="{40EA3D5A-36C4-48EA-916B-CE535004CE0B}" dt="2025-08-23T09:30:54.777" v="7" actId="47"/>
-        <pc:sldMkLst>
-          <pc:docMk/>
-          <pc:sldMk cId="706568294" sldId="266"/>
-        </pc:sldMkLst>
-      </pc:sldChg>
-      <pc:sldChg chg="add del">
-        <pc:chgData name="JORGE GALLUD CANO" userId="aa07a950-3061-465d-9845-1f16ea714d1e" providerId="ADAL" clId="{40EA3D5A-36C4-48EA-916B-CE535004CE0B}" dt="2025-08-23T09:30:54.777" v="7" actId="47"/>
-        <pc:sldMkLst>
-          <pc:docMk/>
-          <pc:sldMk cId="1848052176" sldId="267"/>
-        </pc:sldMkLst>
-      </pc:sldChg>
-      <pc:sldChg chg="add del">
-        <pc:chgData name="JORGE GALLUD CANO" userId="aa07a950-3061-465d-9845-1f16ea714d1e" providerId="ADAL" clId="{40EA3D5A-36C4-48EA-916B-CE535004CE0B}" dt="2025-08-23T09:30:54.777" v="7" actId="47"/>
-        <pc:sldMkLst>
-          <pc:docMk/>
-          <pc:sldMk cId="2055150764" sldId="268"/>
-        </pc:sldMkLst>
-      </pc:sldChg>
-      <pc:sldChg chg="add del">
-        <pc:chgData name="JORGE GALLUD CANO" userId="aa07a950-3061-465d-9845-1f16ea714d1e" providerId="ADAL" clId="{40EA3D5A-36C4-48EA-916B-CE535004CE0B}" dt="2025-08-23T09:30:54.777" v="7" actId="47"/>
-        <pc:sldMkLst>
-          <pc:docMk/>
-          <pc:sldMk cId="1220813665" sldId="269"/>
-        </pc:sldMkLst>
-      </pc:sldChg>
-      <pc:sldChg chg="add del">
-        <pc:chgData name="JORGE GALLUD CANO" userId="aa07a950-3061-465d-9845-1f16ea714d1e" providerId="ADAL" clId="{40EA3D5A-36C4-48EA-916B-CE535004CE0B}" dt="2025-08-23T09:30:59.576" v="8" actId="47"/>
-        <pc:sldMkLst>
-          <pc:docMk/>
-          <pc:sldMk cId="1599127546" sldId="270"/>
-        </pc:sldMkLst>
-      </pc:sldChg>
-      <pc:sldChg chg="modSp mod">
-        <pc:chgData name="JORGE GALLUD CANO" userId="aa07a950-3061-465d-9845-1f16ea714d1e" providerId="ADAL" clId="{40EA3D5A-36C4-48EA-916B-CE535004CE0B}" dt="2025-08-23T10:24:23.660" v="318" actId="20577"/>
-        <pc:sldMkLst>
-          <pc:docMk/>
-          <pc:sldMk cId="3654454351" sldId="276"/>
-        </pc:sldMkLst>
-        <pc:spChg chg="mod">
-          <ac:chgData name="JORGE GALLUD CANO" userId="aa07a950-3061-465d-9845-1f16ea714d1e" providerId="ADAL" clId="{40EA3D5A-36C4-48EA-916B-CE535004CE0B}" dt="2025-08-23T10:24:23.660" v="318" actId="20577"/>
-          <ac:spMkLst>
-            <pc:docMk/>
-            <pc:sldMk cId="3654454351" sldId="276"/>
-            <ac:spMk id="2" creationId="{00000000-0000-0000-0000-000000000000}"/>
-          </ac:spMkLst>
-        </pc:spChg>
-      </pc:sldChg>
-      <pc:sldChg chg="modSp mod">
-        <pc:chgData name="JORGE GALLUD CANO" userId="aa07a950-3061-465d-9845-1f16ea714d1e" providerId="ADAL" clId="{40EA3D5A-36C4-48EA-916B-CE535004CE0B}" dt="2025-08-23T10:17:43.313" v="285" actId="20577"/>
-        <pc:sldMkLst>
-          <pc:docMk/>
-          <pc:sldMk cId="3017756465" sldId="278"/>
-        </pc:sldMkLst>
-        <pc:spChg chg="mod">
-          <ac:chgData name="JORGE GALLUD CANO" userId="aa07a950-3061-465d-9845-1f16ea714d1e" providerId="ADAL" clId="{40EA3D5A-36C4-48EA-916B-CE535004CE0B}" dt="2025-08-23T09:58:23.128" v="260" actId="5793"/>
-          <ac:spMkLst>
-            <pc:docMk/>
-            <pc:sldMk cId="3017756465" sldId="278"/>
-            <ac:spMk id="2" creationId="{00000000-0000-0000-0000-000000000000}"/>
-          </ac:spMkLst>
-        </pc:spChg>
-        <pc:spChg chg="mod">
-          <ac:chgData name="JORGE GALLUD CANO" userId="aa07a950-3061-465d-9845-1f16ea714d1e" providerId="ADAL" clId="{40EA3D5A-36C4-48EA-916B-CE535004CE0B}" dt="2025-08-23T10:17:43.313" v="285" actId="20577"/>
-          <ac:spMkLst>
-            <pc:docMk/>
-            <pc:sldMk cId="3017756465" sldId="278"/>
-            <ac:spMk id="3" creationId="{00000000-0000-0000-0000-000000000000}"/>
-          </ac:spMkLst>
-        </pc:spChg>
-      </pc:sldChg>
-      <pc:sldChg chg="add del">
-        <pc:chgData name="JORGE GALLUD CANO" userId="aa07a950-3061-465d-9845-1f16ea714d1e" providerId="ADAL" clId="{40EA3D5A-36C4-48EA-916B-CE535004CE0B}" dt="2025-08-23T09:30:54.777" v="7" actId="47"/>
-        <pc:sldMkLst>
-          <pc:docMk/>
-          <pc:sldMk cId="1005136347" sldId="287"/>
-        </pc:sldMkLst>
-      </pc:sldChg>
-      <pc:sldChg chg="modSp mod">
-        <pc:chgData name="JORGE GALLUD CANO" userId="aa07a950-3061-465d-9845-1f16ea714d1e" providerId="ADAL" clId="{40EA3D5A-36C4-48EA-916B-CE535004CE0B}" dt="2025-08-23T09:41:55.182" v="88" actId="2710"/>
-        <pc:sldMkLst>
-          <pc:docMk/>
-          <pc:sldMk cId="4275845143" sldId="296"/>
-        </pc:sldMkLst>
-        <pc:spChg chg="mod">
-          <ac:chgData name="JORGE GALLUD CANO" userId="aa07a950-3061-465d-9845-1f16ea714d1e" providerId="ADAL" clId="{40EA3D5A-36C4-48EA-916B-CE535004CE0B}" dt="2025-08-23T09:32:03.340" v="18" actId="20577"/>
-          <ac:spMkLst>
-            <pc:docMk/>
-            <pc:sldMk cId="4275845143" sldId="296"/>
-            <ac:spMk id="2" creationId="{00000000-0000-0000-0000-000000000000}"/>
-          </ac:spMkLst>
-        </pc:spChg>
-        <pc:spChg chg="mod">
-          <ac:chgData name="JORGE GALLUD CANO" userId="aa07a950-3061-465d-9845-1f16ea714d1e" providerId="ADAL" clId="{40EA3D5A-36C4-48EA-916B-CE535004CE0B}" dt="2025-08-23T09:41:55.182" v="88" actId="2710"/>
-          <ac:spMkLst>
-            <pc:docMk/>
-            <pc:sldMk cId="4275845143" sldId="296"/>
-            <ac:spMk id="3" creationId="{00000000-0000-0000-0000-000000000000}"/>
-          </ac:spMkLst>
-        </pc:spChg>
-      </pc:sldChg>
-      <pc:sldChg chg="add del">
-        <pc:chgData name="JORGE GALLUD CANO" userId="aa07a950-3061-465d-9845-1f16ea714d1e" providerId="ADAL" clId="{40EA3D5A-36C4-48EA-916B-CE535004CE0B}" dt="2025-08-23T09:30:37.303" v="6" actId="47"/>
-        <pc:sldMkLst>
-          <pc:docMk/>
-          <pc:sldMk cId="0" sldId="304"/>
-        </pc:sldMkLst>
-      </pc:sldChg>
-      <pc:sldChg chg="add del">
-        <pc:chgData name="JORGE GALLUD CANO" userId="aa07a950-3061-465d-9845-1f16ea714d1e" providerId="ADAL" clId="{40EA3D5A-36C4-48EA-916B-CE535004CE0B}" dt="2025-08-23T09:30:37.303" v="6" actId="47"/>
-        <pc:sldMkLst>
-          <pc:docMk/>
-          <pc:sldMk cId="1952336111" sldId="315"/>
-        </pc:sldMkLst>
-      </pc:sldChg>
-      <pc:sldChg chg="del">
-        <pc:chgData name="JORGE GALLUD CANO" userId="aa07a950-3061-465d-9845-1f16ea714d1e" providerId="ADAL" clId="{40EA3D5A-36C4-48EA-916B-CE535004CE0B}" dt="2025-08-23T09:30:37.303" v="6" actId="47"/>
-        <pc:sldMkLst>
-          <pc:docMk/>
-          <pc:sldMk cId="3801989857" sldId="316"/>
-        </pc:sldMkLst>
-      </pc:sldChg>
-      <pc:sldChg chg="del">
-        <pc:chgData name="JORGE GALLUD CANO" userId="aa07a950-3061-465d-9845-1f16ea714d1e" providerId="ADAL" clId="{40EA3D5A-36C4-48EA-916B-CE535004CE0B}" dt="2025-08-23T09:30:37.303" v="6" actId="47"/>
-        <pc:sldMkLst>
-          <pc:docMk/>
-          <pc:sldMk cId="0" sldId="317"/>
-        </pc:sldMkLst>
-      </pc:sldChg>
-      <pc:sldChg chg="del">
-        <pc:chgData name="JORGE GALLUD CANO" userId="aa07a950-3061-465d-9845-1f16ea714d1e" providerId="ADAL" clId="{40EA3D5A-36C4-48EA-916B-CE535004CE0B}" dt="2025-08-23T09:30:37.303" v="6" actId="47"/>
-        <pc:sldMkLst>
-          <pc:docMk/>
-          <pc:sldMk cId="0" sldId="318"/>
-        </pc:sldMkLst>
-      </pc:sldChg>
-      <pc:sldChg chg="del">
-        <pc:chgData name="JORGE GALLUD CANO" userId="aa07a950-3061-465d-9845-1f16ea714d1e" providerId="ADAL" clId="{40EA3D5A-36C4-48EA-916B-CE535004CE0B}" dt="2025-08-23T09:30:37.303" v="6" actId="47"/>
-        <pc:sldMkLst>
-          <pc:docMk/>
-          <pc:sldMk cId="0" sldId="319"/>
-        </pc:sldMkLst>
-      </pc:sldChg>
-      <pc:sldChg chg="del">
-        <pc:chgData name="JORGE GALLUD CANO" userId="aa07a950-3061-465d-9845-1f16ea714d1e" providerId="ADAL" clId="{40EA3D5A-36C4-48EA-916B-CE535004CE0B}" dt="2025-08-23T09:30:37.303" v="6" actId="47"/>
-        <pc:sldMkLst>
-          <pc:docMk/>
-          <pc:sldMk cId="2013899992" sldId="321"/>
-        </pc:sldMkLst>
-      </pc:sldChg>
-      <pc:sldChg chg="del">
-        <pc:chgData name="JORGE GALLUD CANO" userId="aa07a950-3061-465d-9845-1f16ea714d1e" providerId="ADAL" clId="{40EA3D5A-36C4-48EA-916B-CE535004CE0B}" dt="2025-08-23T09:30:37.303" v="6" actId="47"/>
-        <pc:sldMkLst>
-          <pc:docMk/>
-          <pc:sldMk cId="3885165775" sldId="322"/>
-        </pc:sldMkLst>
-      </pc:sldChg>
-      <pc:sldChg chg="del">
-        <pc:chgData name="JORGE GALLUD CANO" userId="aa07a950-3061-465d-9845-1f16ea714d1e" providerId="ADAL" clId="{40EA3D5A-36C4-48EA-916B-CE535004CE0B}" dt="2025-08-23T09:30:37.303" v="6" actId="47"/>
-        <pc:sldMkLst>
-          <pc:docMk/>
-          <pc:sldMk cId="0" sldId="323"/>
-        </pc:sldMkLst>
-      </pc:sldChg>
-      <pc:sldChg chg="del">
-        <pc:chgData name="JORGE GALLUD CANO" userId="aa07a950-3061-465d-9845-1f16ea714d1e" providerId="ADAL" clId="{40EA3D5A-36C4-48EA-916B-CE535004CE0B}" dt="2025-08-23T09:30:37.303" v="6" actId="47"/>
-        <pc:sldMkLst>
-          <pc:docMk/>
-          <pc:sldMk cId="0" sldId="324"/>
-        </pc:sldMkLst>
-      </pc:sldChg>
-      <pc:sldChg chg="del">
-        <pc:chgData name="JORGE GALLUD CANO" userId="aa07a950-3061-465d-9845-1f16ea714d1e" providerId="ADAL" clId="{40EA3D5A-36C4-48EA-916B-CE535004CE0B}" dt="2025-08-23T09:30:37.303" v="6" actId="47"/>
-        <pc:sldMkLst>
-          <pc:docMk/>
-          <pc:sldMk cId="0" sldId="325"/>
-        </pc:sldMkLst>
-      </pc:sldChg>
-      <pc:sldChg chg="del">
-        <pc:chgData name="JORGE GALLUD CANO" userId="aa07a950-3061-465d-9845-1f16ea714d1e" providerId="ADAL" clId="{40EA3D5A-36C4-48EA-916B-CE535004CE0B}" dt="2025-08-23T09:30:37.303" v="6" actId="47"/>
-        <pc:sldMkLst>
-          <pc:docMk/>
-          <pc:sldMk cId="0" sldId="326"/>
-        </pc:sldMkLst>
-      </pc:sldChg>
-      <pc:sldChg chg="del">
-        <pc:chgData name="JORGE GALLUD CANO" userId="aa07a950-3061-465d-9845-1f16ea714d1e" providerId="ADAL" clId="{40EA3D5A-36C4-48EA-916B-CE535004CE0B}" dt="2025-08-23T09:30:37.303" v="6" actId="47"/>
-        <pc:sldMkLst>
-          <pc:docMk/>
-          <pc:sldMk cId="0" sldId="336"/>
-        </pc:sldMkLst>
-      </pc:sldChg>
-      <pc:sldChg chg="del">
-        <pc:chgData name="JORGE GALLUD CANO" userId="aa07a950-3061-465d-9845-1f16ea714d1e" providerId="ADAL" clId="{40EA3D5A-36C4-48EA-916B-CE535004CE0B}" dt="2025-08-23T09:30:37.303" v="6" actId="47"/>
-        <pc:sldMkLst>
-          <pc:docMk/>
-          <pc:sldMk cId="0" sldId="339"/>
-        </pc:sldMkLst>
-      </pc:sldChg>
-      <pc:sldChg chg="add del">
-        <pc:chgData name="JORGE GALLUD CANO" userId="aa07a950-3061-465d-9845-1f16ea714d1e" providerId="ADAL" clId="{40EA3D5A-36C4-48EA-916B-CE535004CE0B}" dt="2025-08-23T09:30:37.303" v="6" actId="47"/>
-        <pc:sldMkLst>
-          <pc:docMk/>
-          <pc:sldMk cId="4021750541" sldId="369"/>
-        </pc:sldMkLst>
-      </pc:sldChg>
-      <pc:sldChg chg="add del">
-        <pc:chgData name="JORGE GALLUD CANO" userId="aa07a950-3061-465d-9845-1f16ea714d1e" providerId="ADAL" clId="{40EA3D5A-36C4-48EA-916B-CE535004CE0B}" dt="2025-08-23T09:30:37.303" v="6" actId="47"/>
-        <pc:sldMkLst>
-          <pc:docMk/>
-          <pc:sldMk cId="2785731025" sldId="370"/>
-        </pc:sldMkLst>
-      </pc:sldChg>
-      <pc:sldChg chg="del">
-        <pc:chgData name="JORGE GALLUD CANO" userId="aa07a950-3061-465d-9845-1f16ea714d1e" providerId="ADAL" clId="{40EA3D5A-36C4-48EA-916B-CE535004CE0B}" dt="2025-08-23T09:30:37.303" v="6" actId="47"/>
-        <pc:sldMkLst>
-          <pc:docMk/>
-          <pc:sldMk cId="2607650453" sldId="371"/>
-        </pc:sldMkLst>
-      </pc:sldChg>
-      <pc:sldChg chg="del">
-        <pc:chgData name="JORGE GALLUD CANO" userId="aa07a950-3061-465d-9845-1f16ea714d1e" providerId="ADAL" clId="{40EA3D5A-36C4-48EA-916B-CE535004CE0B}" dt="2025-08-23T09:30:37.303" v="6" actId="47"/>
-        <pc:sldMkLst>
-          <pc:docMk/>
-          <pc:sldMk cId="863811219" sldId="372"/>
-        </pc:sldMkLst>
-      </pc:sldChg>
-      <pc:sldChg chg="del">
-        <pc:chgData name="JORGE GALLUD CANO" userId="aa07a950-3061-465d-9845-1f16ea714d1e" providerId="ADAL" clId="{40EA3D5A-36C4-48EA-916B-CE535004CE0B}" dt="2025-08-23T09:30:37.303" v="6" actId="47"/>
-        <pc:sldMkLst>
-          <pc:docMk/>
-          <pc:sldMk cId="2391918928" sldId="373"/>
-        </pc:sldMkLst>
-      </pc:sldChg>
-      <pc:sldChg chg="del">
-        <pc:chgData name="JORGE GALLUD CANO" userId="aa07a950-3061-465d-9845-1f16ea714d1e" providerId="ADAL" clId="{40EA3D5A-36C4-48EA-916B-CE535004CE0B}" dt="2025-08-23T09:30:37.303" v="6" actId="47"/>
-        <pc:sldMkLst>
-          <pc:docMk/>
-          <pc:sldMk cId="845031517" sldId="374"/>
-        </pc:sldMkLst>
-      </pc:sldChg>
-      <pc:sldChg chg="del">
-        <pc:chgData name="JORGE GALLUD CANO" userId="aa07a950-3061-465d-9845-1f16ea714d1e" providerId="ADAL" clId="{40EA3D5A-36C4-48EA-916B-CE535004CE0B}" dt="2025-08-23T09:30:37.303" v="6" actId="47"/>
-        <pc:sldMkLst>
-          <pc:docMk/>
-          <pc:sldMk cId="537315646" sldId="375"/>
-        </pc:sldMkLst>
-      </pc:sldChg>
-      <pc:sldChg chg="modSp mod modNotesTx">
-        <pc:chgData name="JORGE GALLUD CANO" userId="aa07a950-3061-465d-9845-1f16ea714d1e" providerId="ADAL" clId="{40EA3D5A-36C4-48EA-916B-CE535004CE0B}" dt="2025-08-23T10:22:29.248" v="305" actId="20577"/>
-        <pc:sldMkLst>
-          <pc:docMk/>
-          <pc:sldMk cId="2244167066" sldId="422"/>
-        </pc:sldMkLst>
-        <pc:spChg chg="mod">
-          <ac:chgData name="JORGE GALLUD CANO" userId="aa07a950-3061-465d-9845-1f16ea714d1e" providerId="ADAL" clId="{40EA3D5A-36C4-48EA-916B-CE535004CE0B}" dt="2025-08-23T10:10:09.472" v="272" actId="20577"/>
-          <ac:spMkLst>
-            <pc:docMk/>
-            <pc:sldMk cId="2244167066" sldId="422"/>
-            <ac:spMk id="2" creationId="{00000000-0000-0000-0000-000000000000}"/>
-          </ac:spMkLst>
-        </pc:spChg>
-      </pc:sldChg>
-      <pc:sldChg chg="add del">
-        <pc:chgData name="JORGE GALLUD CANO" userId="aa07a950-3061-465d-9845-1f16ea714d1e" providerId="ADAL" clId="{40EA3D5A-36C4-48EA-916B-CE535004CE0B}" dt="2025-08-23T09:30:54.777" v="7" actId="47"/>
-        <pc:sldMkLst>
-          <pc:docMk/>
-          <pc:sldMk cId="4031023037" sldId="514"/>
-        </pc:sldMkLst>
-      </pc:sldChg>
-      <pc:sldChg chg="modSp mod modNotesTx">
-        <pc:chgData name="JORGE GALLUD CANO" userId="aa07a950-3061-465d-9845-1f16ea714d1e" providerId="ADAL" clId="{40EA3D5A-36C4-48EA-916B-CE535004CE0B}" dt="2025-08-23T09:58:30.986" v="264" actId="20577"/>
-        <pc:sldMkLst>
-          <pc:docMk/>
-          <pc:sldMk cId="3071016736" sldId="525"/>
-        </pc:sldMkLst>
-        <pc:spChg chg="mod">
-          <ac:chgData name="JORGE GALLUD CANO" userId="aa07a950-3061-465d-9845-1f16ea714d1e" providerId="ADAL" clId="{40EA3D5A-36C4-48EA-916B-CE535004CE0B}" dt="2025-08-23T09:58:30.986" v="264" actId="20577"/>
-          <ac:spMkLst>
-            <pc:docMk/>
-            <pc:sldMk cId="3071016736" sldId="525"/>
-            <ac:spMk id="2" creationId="{00000000-0000-0000-0000-000000000000}"/>
-          </ac:spMkLst>
-        </pc:spChg>
-      </pc:sldChg>
-      <pc:sldChg chg="add del">
-        <pc:chgData name="JORGE GALLUD CANO" userId="aa07a950-3061-465d-9845-1f16ea714d1e" providerId="ADAL" clId="{40EA3D5A-36C4-48EA-916B-CE535004CE0B}" dt="2025-08-23T09:30:54.777" v="7" actId="47"/>
-        <pc:sldMkLst>
-          <pc:docMk/>
-          <pc:sldMk cId="1231696929" sldId="526"/>
-        </pc:sldMkLst>
-      </pc:sldChg>
-      <pc:sldChg chg="modSp mod">
-        <pc:chgData name="JORGE GALLUD CANO" userId="aa07a950-3061-465d-9845-1f16ea714d1e" providerId="ADAL" clId="{40EA3D5A-36C4-48EA-916B-CE535004CE0B}" dt="2025-08-23T10:28:35.506" v="353" actId="14734"/>
-        <pc:sldMkLst>
-          <pc:docMk/>
-          <pc:sldMk cId="1013920607" sldId="527"/>
-        </pc:sldMkLst>
-        <pc:spChg chg="mod">
-          <ac:chgData name="JORGE GALLUD CANO" userId="aa07a950-3061-465d-9845-1f16ea714d1e" providerId="ADAL" clId="{40EA3D5A-36C4-48EA-916B-CE535004CE0B}" dt="2025-08-23T10:26:42.725" v="319"/>
-          <ac:spMkLst>
-            <pc:docMk/>
-            <pc:sldMk cId="1013920607" sldId="527"/>
-            <ac:spMk id="2" creationId="{00000000-0000-0000-0000-000000000000}"/>
-          </ac:spMkLst>
-        </pc:spChg>
-        <pc:graphicFrameChg chg="mod modGraphic">
-          <ac:chgData name="JORGE GALLUD CANO" userId="aa07a950-3061-465d-9845-1f16ea714d1e" providerId="ADAL" clId="{40EA3D5A-36C4-48EA-916B-CE535004CE0B}" dt="2025-08-23T10:28:35.506" v="353" actId="14734"/>
-          <ac:graphicFrameMkLst>
-            <pc:docMk/>
-            <pc:sldMk cId="1013920607" sldId="527"/>
-            <ac:graphicFrameMk id="5" creationId="{E3E6F599-B490-24FB-9AF1-F6AE69C92B60}"/>
-          </ac:graphicFrameMkLst>
-        </pc:graphicFrameChg>
-      </pc:sldChg>
-      <pc:sldChg chg="modSp mod">
-        <pc:chgData name="JORGE GALLUD CANO" userId="aa07a950-3061-465d-9845-1f16ea714d1e" providerId="ADAL" clId="{40EA3D5A-36C4-48EA-916B-CE535004CE0B}" dt="2025-08-23T10:54:24.402" v="566" actId="20577"/>
-        <pc:sldMkLst>
-          <pc:docMk/>
-          <pc:sldMk cId="2604605080" sldId="528"/>
-        </pc:sldMkLst>
-        <pc:spChg chg="mod">
-          <ac:chgData name="JORGE GALLUD CANO" userId="aa07a950-3061-465d-9845-1f16ea714d1e" providerId="ADAL" clId="{40EA3D5A-36C4-48EA-916B-CE535004CE0B}" dt="2025-08-23T10:28:40.853" v="355" actId="20577"/>
-          <ac:spMkLst>
-            <pc:docMk/>
-            <pc:sldMk cId="2604605080" sldId="528"/>
-            <ac:spMk id="2" creationId="{00000000-0000-0000-0000-000000000000}"/>
-          </ac:spMkLst>
-        </pc:spChg>
-        <pc:spChg chg="mod">
-          <ac:chgData name="JORGE GALLUD CANO" userId="aa07a950-3061-465d-9845-1f16ea714d1e" providerId="ADAL" clId="{40EA3D5A-36C4-48EA-916B-CE535004CE0B}" dt="2025-08-23T10:54:24.402" v="566" actId="20577"/>
-          <ac:spMkLst>
-            <pc:docMk/>
-            <pc:sldMk cId="2604605080" sldId="528"/>
-            <ac:spMk id="6" creationId="{211D8BE8-5AF5-00EB-B4B4-EA295A23E1DE}"/>
-          </ac:spMkLst>
-        </pc:spChg>
-      </pc:sldChg>
-      <pc:sldChg chg="modSp mod modNotesTx">
-        <pc:chgData name="JORGE GALLUD CANO" userId="aa07a950-3061-465d-9845-1f16ea714d1e" providerId="ADAL" clId="{40EA3D5A-36C4-48EA-916B-CE535004CE0B}" dt="2025-08-23T10:45:25.064" v="490" actId="20577"/>
-        <pc:sldMkLst>
-          <pc:docMk/>
-          <pc:sldMk cId="2422460302" sldId="529"/>
-        </pc:sldMkLst>
-        <pc:spChg chg="mod">
-          <ac:chgData name="JORGE GALLUD CANO" userId="aa07a950-3061-465d-9845-1f16ea714d1e" providerId="ADAL" clId="{40EA3D5A-36C4-48EA-916B-CE535004CE0B}" dt="2025-08-23T10:45:25.064" v="490" actId="20577"/>
-          <ac:spMkLst>
-            <pc:docMk/>
-            <pc:sldMk cId="2422460302" sldId="529"/>
-            <ac:spMk id="6" creationId="{211D8BE8-5AF5-00EB-B4B4-EA295A23E1DE}"/>
-          </ac:spMkLst>
-        </pc:spChg>
-      </pc:sldChg>
-      <pc:sldChg chg="modSp mod modNotesTx">
-        <pc:chgData name="JORGE GALLUD CANO" userId="aa07a950-3061-465d-9845-1f16ea714d1e" providerId="ADAL" clId="{40EA3D5A-36C4-48EA-916B-CE535004CE0B}" dt="2025-08-23T10:55:58.152" v="601" actId="20577"/>
-        <pc:sldMkLst>
-          <pc:docMk/>
-          <pc:sldMk cId="242827117" sldId="530"/>
-        </pc:sldMkLst>
-        <pc:spChg chg="mod">
-          <ac:chgData name="JORGE GALLUD CANO" userId="aa07a950-3061-465d-9845-1f16ea714d1e" providerId="ADAL" clId="{40EA3D5A-36C4-48EA-916B-CE535004CE0B}" dt="2025-08-23T10:55:26.264" v="591" actId="20577"/>
-          <ac:spMkLst>
-            <pc:docMk/>
-            <pc:sldMk cId="242827117" sldId="530"/>
-            <ac:spMk id="6" creationId="{211D8BE8-5AF5-00EB-B4B4-EA295A23E1DE}"/>
-          </ac:spMkLst>
-        </pc:spChg>
-      </pc:sldChg>
-      <pc:sldChg chg="add del">
-        <pc:chgData name="JORGE GALLUD CANO" userId="aa07a950-3061-465d-9845-1f16ea714d1e" providerId="ADAL" clId="{40EA3D5A-36C4-48EA-916B-CE535004CE0B}" dt="2025-08-23T09:30:54.777" v="7" actId="47"/>
-        <pc:sldMkLst>
-          <pc:docMk/>
-          <pc:sldMk cId="3622248180" sldId="531"/>
-        </pc:sldMkLst>
-      </pc:sldChg>
-      <pc:sldChg chg="add del">
-        <pc:chgData name="JORGE GALLUD CANO" userId="aa07a950-3061-465d-9845-1f16ea714d1e" providerId="ADAL" clId="{40EA3D5A-36C4-48EA-916B-CE535004CE0B}" dt="2025-08-23T09:30:54.777" v="7" actId="47"/>
-        <pc:sldMkLst>
-          <pc:docMk/>
-          <pc:sldMk cId="481370698" sldId="532"/>
-        </pc:sldMkLst>
-      </pc:sldChg>
-      <pc:sldChg chg="add del">
-        <pc:chgData name="JORGE GALLUD CANO" userId="aa07a950-3061-465d-9845-1f16ea714d1e" providerId="ADAL" clId="{40EA3D5A-36C4-48EA-916B-CE535004CE0B}" dt="2025-08-23T09:30:54.777" v="7" actId="47"/>
-        <pc:sldMkLst>
-          <pc:docMk/>
-          <pc:sldMk cId="3728224116" sldId="533"/>
-        </pc:sldMkLst>
-      </pc:sldChg>
-      <pc:sldChg chg="add del">
-        <pc:chgData name="JORGE GALLUD CANO" userId="aa07a950-3061-465d-9845-1f16ea714d1e" providerId="ADAL" clId="{40EA3D5A-36C4-48EA-916B-CE535004CE0B}" dt="2025-08-23T09:30:54.777" v="7" actId="47"/>
-        <pc:sldMkLst>
-          <pc:docMk/>
-          <pc:sldMk cId="3386124033" sldId="534"/>
-        </pc:sldMkLst>
-      </pc:sldChg>
-      <pc:sldChg chg="add del">
-        <pc:chgData name="JORGE GALLUD CANO" userId="aa07a950-3061-465d-9845-1f16ea714d1e" providerId="ADAL" clId="{40EA3D5A-36C4-48EA-916B-CE535004CE0B}" dt="2025-08-23T09:30:54.777" v="7" actId="47"/>
-        <pc:sldMkLst>
-          <pc:docMk/>
-          <pc:sldMk cId="3912472103" sldId="535"/>
-        </pc:sldMkLst>
-      </pc:sldChg>
-      <pc:sldChg chg="add del">
-        <pc:chgData name="JORGE GALLUD CANO" userId="aa07a950-3061-465d-9845-1f16ea714d1e" providerId="ADAL" clId="{40EA3D5A-36C4-48EA-916B-CE535004CE0B}" dt="2025-08-23T09:30:54.777" v="7" actId="47"/>
-        <pc:sldMkLst>
-          <pc:docMk/>
-          <pc:sldMk cId="707880807" sldId="536"/>
-        </pc:sldMkLst>
-      </pc:sldChg>
-      <pc:sldChg chg="add del">
-        <pc:chgData name="JORGE GALLUD CANO" userId="aa07a950-3061-465d-9845-1f16ea714d1e" providerId="ADAL" clId="{40EA3D5A-36C4-48EA-916B-CE535004CE0B}" dt="2025-08-23T09:30:54.777" v="7" actId="47"/>
-        <pc:sldMkLst>
-          <pc:docMk/>
-          <pc:sldMk cId="465850784" sldId="537"/>
-        </pc:sldMkLst>
-      </pc:sldChg>
-      <pc:sldChg chg="add del">
-        <pc:chgData name="JORGE GALLUD CANO" userId="aa07a950-3061-465d-9845-1f16ea714d1e" providerId="ADAL" clId="{40EA3D5A-36C4-48EA-916B-CE535004CE0B}" dt="2025-08-23T09:30:54.777" v="7" actId="47"/>
-        <pc:sldMkLst>
-          <pc:docMk/>
-          <pc:sldMk cId="4067792214" sldId="538"/>
-        </pc:sldMkLst>
-      </pc:sldChg>
-      <pc:sldChg chg="add del">
-        <pc:chgData name="JORGE GALLUD CANO" userId="aa07a950-3061-465d-9845-1f16ea714d1e" providerId="ADAL" clId="{40EA3D5A-36C4-48EA-916B-CE535004CE0B}" dt="2025-08-23T09:30:54.777" v="7" actId="47"/>
-        <pc:sldMkLst>
-          <pc:docMk/>
-          <pc:sldMk cId="1448990937" sldId="539"/>
-        </pc:sldMkLst>
-      </pc:sldChg>
-      <pc:sldChg chg="add del">
-        <pc:chgData name="JORGE GALLUD CANO" userId="aa07a950-3061-465d-9845-1f16ea714d1e" providerId="ADAL" clId="{40EA3D5A-36C4-48EA-916B-CE535004CE0B}" dt="2025-08-23T09:30:54.777" v="7" actId="47"/>
-        <pc:sldMkLst>
-          <pc:docMk/>
-          <pc:sldMk cId="955192983" sldId="540"/>
-        </pc:sldMkLst>
-      </pc:sldChg>
-      <pc:sldChg chg="add del">
-        <pc:chgData name="JORGE GALLUD CANO" userId="aa07a950-3061-465d-9845-1f16ea714d1e" providerId="ADAL" clId="{40EA3D5A-36C4-48EA-916B-CE535004CE0B}" dt="2025-08-23T09:30:54.777" v="7" actId="47"/>
-        <pc:sldMkLst>
-          <pc:docMk/>
-          <pc:sldMk cId="3848481124" sldId="541"/>
-        </pc:sldMkLst>
-      </pc:sldChg>
-      <pc:sldChg chg="add del">
-        <pc:chgData name="JORGE GALLUD CANO" userId="aa07a950-3061-465d-9845-1f16ea714d1e" providerId="ADAL" clId="{40EA3D5A-36C4-48EA-916B-CE535004CE0B}" dt="2025-08-23T09:30:54.777" v="7" actId="47"/>
-        <pc:sldMkLst>
-          <pc:docMk/>
-          <pc:sldMk cId="1306932417" sldId="542"/>
-        </pc:sldMkLst>
-      </pc:sldChg>
-      <pc:sldChg chg="add del">
-        <pc:chgData name="JORGE GALLUD CANO" userId="aa07a950-3061-465d-9845-1f16ea714d1e" providerId="ADAL" clId="{40EA3D5A-36C4-48EA-916B-CE535004CE0B}" dt="2025-08-23T09:30:54.777" v="7" actId="47"/>
-        <pc:sldMkLst>
-          <pc:docMk/>
-          <pc:sldMk cId="112043818" sldId="543"/>
-        </pc:sldMkLst>
-      </pc:sldChg>
-      <pc:sldChg chg="add del">
-        <pc:chgData name="JORGE GALLUD CANO" userId="aa07a950-3061-465d-9845-1f16ea714d1e" providerId="ADAL" clId="{40EA3D5A-36C4-48EA-916B-CE535004CE0B}" dt="2025-08-23T09:30:54.777" v="7" actId="47"/>
-        <pc:sldMkLst>
-          <pc:docMk/>
-          <pc:sldMk cId="3834304839" sldId="544"/>
-        </pc:sldMkLst>
-      </pc:sldChg>
-      <pc:sldChg chg="add del">
-        <pc:chgData name="JORGE GALLUD CANO" userId="aa07a950-3061-465d-9845-1f16ea714d1e" providerId="ADAL" clId="{40EA3D5A-36C4-48EA-916B-CE535004CE0B}" dt="2025-08-23T09:30:54.777" v="7" actId="47"/>
-        <pc:sldMkLst>
-          <pc:docMk/>
-          <pc:sldMk cId="2999834531" sldId="545"/>
-        </pc:sldMkLst>
-      </pc:sldChg>
-      <pc:sldChg chg="add del">
-        <pc:chgData name="JORGE GALLUD CANO" userId="aa07a950-3061-465d-9845-1f16ea714d1e" providerId="ADAL" clId="{40EA3D5A-36C4-48EA-916B-CE535004CE0B}" dt="2025-08-23T09:30:54.777" v="7" actId="47"/>
-        <pc:sldMkLst>
-          <pc:docMk/>
-          <pc:sldMk cId="3977175055" sldId="546"/>
-        </pc:sldMkLst>
-      </pc:sldChg>
-      <pc:sldChg chg="add del">
-        <pc:chgData name="JORGE GALLUD CANO" userId="aa07a950-3061-465d-9845-1f16ea714d1e" providerId="ADAL" clId="{40EA3D5A-36C4-48EA-916B-CE535004CE0B}" dt="2025-08-23T09:30:54.777" v="7" actId="47"/>
-        <pc:sldMkLst>
-          <pc:docMk/>
-          <pc:sldMk cId="1563079690" sldId="547"/>
-        </pc:sldMkLst>
-      </pc:sldChg>
-      <pc:sldChg chg="add del">
-        <pc:chgData name="JORGE GALLUD CANO" userId="aa07a950-3061-465d-9845-1f16ea714d1e" providerId="ADAL" clId="{40EA3D5A-36C4-48EA-916B-CE535004CE0B}" dt="2025-08-23T09:30:54.777" v="7" actId="47"/>
-        <pc:sldMkLst>
-          <pc:docMk/>
-          <pc:sldMk cId="608954207" sldId="548"/>
-        </pc:sldMkLst>
-      </pc:sldChg>
-      <pc:sldChg chg="add del">
-        <pc:chgData name="JORGE GALLUD CANO" userId="aa07a950-3061-465d-9845-1f16ea714d1e" providerId="ADAL" clId="{40EA3D5A-36C4-48EA-916B-CE535004CE0B}" dt="2025-08-23T09:30:54.777" v="7" actId="47"/>
-        <pc:sldMkLst>
-          <pc:docMk/>
-          <pc:sldMk cId="2495028577" sldId="549"/>
-        </pc:sldMkLst>
-      </pc:sldChg>
-      <pc:sldChg chg="add del">
-        <pc:chgData name="JORGE GALLUD CANO" userId="aa07a950-3061-465d-9845-1f16ea714d1e" providerId="ADAL" clId="{40EA3D5A-36C4-48EA-916B-CE535004CE0B}" dt="2025-08-23T09:30:54.777" v="7" actId="47"/>
-        <pc:sldMkLst>
-          <pc:docMk/>
-          <pc:sldMk cId="198734755" sldId="550"/>
-        </pc:sldMkLst>
-      </pc:sldChg>
-      <pc:sldChg chg="add del">
-        <pc:chgData name="JORGE GALLUD CANO" userId="aa07a950-3061-465d-9845-1f16ea714d1e" providerId="ADAL" clId="{40EA3D5A-36C4-48EA-916B-CE535004CE0B}" dt="2025-08-23T09:30:54.777" v="7" actId="47"/>
-        <pc:sldMkLst>
-          <pc:docMk/>
-          <pc:sldMk cId="2871274626" sldId="551"/>
-        </pc:sldMkLst>
-      </pc:sldChg>
-      <pc:sldChg chg="add del">
-        <pc:chgData name="JORGE GALLUD CANO" userId="aa07a950-3061-465d-9845-1f16ea714d1e" providerId="ADAL" clId="{40EA3D5A-36C4-48EA-916B-CE535004CE0B}" dt="2025-08-23T09:30:54.777" v="7" actId="47"/>
-        <pc:sldMkLst>
-          <pc:docMk/>
-          <pc:sldMk cId="585274247" sldId="552"/>
-        </pc:sldMkLst>
-      </pc:sldChg>
-      <pc:sldChg chg="add del">
-        <pc:chgData name="JORGE GALLUD CANO" userId="aa07a950-3061-465d-9845-1f16ea714d1e" providerId="ADAL" clId="{40EA3D5A-36C4-48EA-916B-CE535004CE0B}" dt="2025-08-23T09:30:54.777" v="7" actId="47"/>
-        <pc:sldMkLst>
-          <pc:docMk/>
-          <pc:sldMk cId="727437492" sldId="553"/>
-        </pc:sldMkLst>
-      </pc:sldChg>
-      <pc:sldChg chg="add del">
-        <pc:chgData name="JORGE GALLUD CANO" userId="aa07a950-3061-465d-9845-1f16ea714d1e" providerId="ADAL" clId="{40EA3D5A-36C4-48EA-916B-CE535004CE0B}" dt="2025-08-23T09:30:54.777" v="7" actId="47"/>
-        <pc:sldMkLst>
-          <pc:docMk/>
-          <pc:sldMk cId="1405569845" sldId="554"/>
-        </pc:sldMkLst>
-      </pc:sldChg>
-      <pc:sldChg chg="add del">
-        <pc:chgData name="JORGE GALLUD CANO" userId="aa07a950-3061-465d-9845-1f16ea714d1e" providerId="ADAL" clId="{40EA3D5A-36C4-48EA-916B-CE535004CE0B}" dt="2025-08-23T09:30:54.777" v="7" actId="47"/>
-        <pc:sldMkLst>
-          <pc:docMk/>
-          <pc:sldMk cId="1757646886" sldId="555"/>
-        </pc:sldMkLst>
-      </pc:sldChg>
-      <pc:sldChg chg="add del">
-        <pc:chgData name="JORGE GALLUD CANO" userId="aa07a950-3061-465d-9845-1f16ea714d1e" providerId="ADAL" clId="{40EA3D5A-36C4-48EA-916B-CE535004CE0B}" dt="2025-08-23T09:30:54.777" v="7" actId="47"/>
-        <pc:sldMkLst>
-          <pc:docMk/>
-          <pc:sldMk cId="498805622" sldId="556"/>
-        </pc:sldMkLst>
-      </pc:sldChg>
-      <pc:sldChg chg="add del">
-        <pc:chgData name="JORGE GALLUD CANO" userId="aa07a950-3061-465d-9845-1f16ea714d1e" providerId="ADAL" clId="{40EA3D5A-36C4-48EA-916B-CE535004CE0B}" dt="2025-08-23T09:30:54.777" v="7" actId="47"/>
-        <pc:sldMkLst>
-          <pc:docMk/>
-          <pc:sldMk cId="3980255656" sldId="557"/>
-        </pc:sldMkLst>
-      </pc:sldChg>
-      <pc:sldChg chg="add del">
-        <pc:chgData name="JORGE GALLUD CANO" userId="aa07a950-3061-465d-9845-1f16ea714d1e" providerId="ADAL" clId="{40EA3D5A-36C4-48EA-916B-CE535004CE0B}" dt="2025-08-23T09:30:54.777" v="7" actId="47"/>
-        <pc:sldMkLst>
-          <pc:docMk/>
-          <pc:sldMk cId="572385549" sldId="558"/>
-        </pc:sldMkLst>
-      </pc:sldChg>
-      <pc:sldChg chg="add del">
-        <pc:chgData name="JORGE GALLUD CANO" userId="aa07a950-3061-465d-9845-1f16ea714d1e" providerId="ADAL" clId="{40EA3D5A-36C4-48EA-916B-CE535004CE0B}" dt="2025-08-23T09:30:54.777" v="7" actId="47"/>
-        <pc:sldMkLst>
-          <pc:docMk/>
-          <pc:sldMk cId="171635713" sldId="559"/>
-        </pc:sldMkLst>
-      </pc:sldChg>
-      <pc:sldChg chg="del">
-        <pc:chgData name="JORGE GALLUD CANO" userId="aa07a950-3061-465d-9845-1f16ea714d1e" providerId="ADAL" clId="{40EA3D5A-36C4-48EA-916B-CE535004CE0B}" dt="2025-08-23T09:30:37.303" v="6" actId="47"/>
-        <pc:sldMkLst>
-          <pc:docMk/>
-          <pc:sldMk cId="2549226878" sldId="560"/>
-        </pc:sldMkLst>
-      </pc:sldChg>
-      <pc:sldChg chg="del">
-        <pc:chgData name="JORGE GALLUD CANO" userId="aa07a950-3061-465d-9845-1f16ea714d1e" providerId="ADAL" clId="{40EA3D5A-36C4-48EA-916B-CE535004CE0B}" dt="2025-08-23T09:30:37.303" v="6" actId="47"/>
-        <pc:sldMkLst>
-          <pc:docMk/>
-          <pc:sldMk cId="0" sldId="561"/>
-        </pc:sldMkLst>
-      </pc:sldChg>
-      <pc:sldChg chg="del">
-        <pc:chgData name="JORGE GALLUD CANO" userId="aa07a950-3061-465d-9845-1f16ea714d1e" providerId="ADAL" clId="{40EA3D5A-36C4-48EA-916B-CE535004CE0B}" dt="2025-08-23T09:30:37.303" v="6" actId="47"/>
-        <pc:sldMkLst>
-          <pc:docMk/>
-          <pc:sldMk cId="4222404445" sldId="562"/>
-        </pc:sldMkLst>
-      </pc:sldChg>
-      <pc:sldChg chg="del">
-        <pc:chgData name="JORGE GALLUD CANO" userId="aa07a950-3061-465d-9845-1f16ea714d1e" providerId="ADAL" clId="{40EA3D5A-36C4-48EA-916B-CE535004CE0B}" dt="2025-08-23T09:30:37.303" v="6" actId="47"/>
-        <pc:sldMkLst>
-          <pc:docMk/>
-          <pc:sldMk cId="386519322" sldId="563"/>
-        </pc:sldMkLst>
-      </pc:sldChg>
-      <pc:sldChg chg="del">
-        <pc:chgData name="JORGE GALLUD CANO" userId="aa07a950-3061-465d-9845-1f16ea714d1e" providerId="ADAL" clId="{40EA3D5A-36C4-48EA-916B-CE535004CE0B}" dt="2025-08-23T09:30:37.303" v="6" actId="47"/>
-        <pc:sldMkLst>
-          <pc:docMk/>
-          <pc:sldMk cId="1967072604" sldId="564"/>
-        </pc:sldMkLst>
-      </pc:sldChg>
-      <pc:sldChg chg="del">
-        <pc:chgData name="JORGE GALLUD CANO" userId="aa07a950-3061-465d-9845-1f16ea714d1e" providerId="ADAL" clId="{40EA3D5A-36C4-48EA-916B-CE535004CE0B}" dt="2025-08-23T09:30:37.303" v="6" actId="47"/>
-        <pc:sldMkLst>
-          <pc:docMk/>
-          <pc:sldMk cId="3947039945" sldId="565"/>
-        </pc:sldMkLst>
-      </pc:sldChg>
-    </pc:docChg>
-  </pc:docChgLst>
-  <pc:docChgLst>
-    <pc:chgData name="JORGE GALLUD CANO" userId="aa07a950-3061-465d-9845-1f16ea714d1e" providerId="ADAL" clId="{E31950EB-08BC-4E48-96C9-D7EFC5D50408}"/>
-    <pc:docChg chg="undo custSel addSld modSld sldOrd modNotesMaster modHandout">
-      <pc:chgData name="JORGE GALLUD CANO" userId="aa07a950-3061-465d-9845-1f16ea714d1e" providerId="ADAL" clId="{E31950EB-08BC-4E48-96C9-D7EFC5D50408}" dt="2025-09-05T09:11:29.650" v="465" actId="6549"/>
-      <pc:docMkLst>
-        <pc:docMk/>
-      </pc:docMkLst>
-      <pc:sldChg chg="modSp mod">
-        <pc:chgData name="JORGE GALLUD CANO" userId="aa07a950-3061-465d-9845-1f16ea714d1e" providerId="ADAL" clId="{E31950EB-08BC-4E48-96C9-D7EFC5D50408}" dt="2025-09-03T10:56:00.779" v="230" actId="20577"/>
-        <pc:sldMkLst>
-          <pc:docMk/>
-          <pc:sldMk cId="24379685" sldId="256"/>
-        </pc:sldMkLst>
-        <pc:spChg chg="mod">
-          <ac:chgData name="JORGE GALLUD CANO" userId="aa07a950-3061-465d-9845-1f16ea714d1e" providerId="ADAL" clId="{E31950EB-08BC-4E48-96C9-D7EFC5D50408}" dt="2025-09-03T10:56:00.779" v="230" actId="20577"/>
-          <ac:spMkLst>
-            <pc:docMk/>
-            <pc:sldMk cId="24379685" sldId="256"/>
-            <ac:spMk id="3" creationId="{00000000-0000-0000-0000-000000000000}"/>
-          </ac:spMkLst>
-        </pc:spChg>
-      </pc:sldChg>
-      <pc:sldChg chg="modSp mod">
-        <pc:chgData name="JORGE GALLUD CANO" userId="aa07a950-3061-465d-9845-1f16ea714d1e" providerId="ADAL" clId="{E31950EB-08BC-4E48-96C9-D7EFC5D50408}" dt="2025-09-03T10:55:29.378" v="224" actId="20577"/>
-        <pc:sldMkLst>
-          <pc:docMk/>
-          <pc:sldMk cId="178495425" sldId="257"/>
-        </pc:sldMkLst>
-        <pc:spChg chg="mod">
-          <ac:chgData name="JORGE GALLUD CANO" userId="aa07a950-3061-465d-9845-1f16ea714d1e" providerId="ADAL" clId="{E31950EB-08BC-4E48-96C9-D7EFC5D50408}" dt="2025-09-03T10:55:29.378" v="224" actId="20577"/>
-          <ac:spMkLst>
-            <pc:docMk/>
-            <pc:sldMk cId="178495425" sldId="257"/>
-            <ac:spMk id="3" creationId="{00000000-0000-0000-0000-000000000000}"/>
-          </ac:spMkLst>
-        </pc:spChg>
-      </pc:sldChg>
-      <pc:sldChg chg="modSp mod">
-        <pc:chgData name="JORGE GALLUD CANO" userId="aa07a950-3061-465d-9845-1f16ea714d1e" providerId="ADAL" clId="{E31950EB-08BC-4E48-96C9-D7EFC5D50408}" dt="2025-09-03T10:48:46.811" v="48" actId="20577"/>
-        <pc:sldMkLst>
-          <pc:docMk/>
-          <pc:sldMk cId="4275845143" sldId="296"/>
-        </pc:sldMkLst>
-        <pc:spChg chg="mod">
-          <ac:chgData name="JORGE GALLUD CANO" userId="aa07a950-3061-465d-9845-1f16ea714d1e" providerId="ADAL" clId="{E31950EB-08BC-4E48-96C9-D7EFC5D50408}" dt="2025-09-03T10:48:46.811" v="48" actId="20577"/>
-          <ac:spMkLst>
-            <pc:docMk/>
-            <pc:sldMk cId="4275845143" sldId="296"/>
-            <ac:spMk id="3" creationId="{00000000-0000-0000-0000-000000000000}"/>
-          </ac:spMkLst>
-        </pc:spChg>
-      </pc:sldChg>
-      <pc:sldChg chg="modSp mod modNotesTx">
-        <pc:chgData name="JORGE GALLUD CANO" userId="aa07a950-3061-465d-9845-1f16ea714d1e" providerId="ADAL" clId="{E31950EB-08BC-4E48-96C9-D7EFC5D50408}" dt="2025-09-03T12:06:10.460" v="255" actId="20577"/>
-        <pc:sldMkLst>
-          <pc:docMk/>
-          <pc:sldMk cId="242827117" sldId="530"/>
-        </pc:sldMkLst>
-        <pc:spChg chg="mod">
-          <ac:chgData name="JORGE GALLUD CANO" userId="aa07a950-3061-465d-9845-1f16ea714d1e" providerId="ADAL" clId="{E31950EB-08BC-4E48-96C9-D7EFC5D50408}" dt="2025-09-03T12:06:10.460" v="255" actId="20577"/>
-          <ac:spMkLst>
-            <pc:docMk/>
-            <pc:sldMk cId="242827117" sldId="530"/>
-            <ac:spMk id="2" creationId="{00000000-0000-0000-0000-000000000000}"/>
-          </ac:spMkLst>
-        </pc:spChg>
-        <pc:spChg chg="mod">
-          <ac:chgData name="JORGE GALLUD CANO" userId="aa07a950-3061-465d-9845-1f16ea714d1e" providerId="ADAL" clId="{E31950EB-08BC-4E48-96C9-D7EFC5D50408}" dt="2025-09-03T12:02:18.248" v="231" actId="20577"/>
-          <ac:spMkLst>
-            <pc:docMk/>
-            <pc:sldMk cId="242827117" sldId="530"/>
-            <ac:spMk id="6" creationId="{211D8BE8-5AF5-00EB-B4B4-EA295A23E1DE}"/>
-          </ac:spMkLst>
-        </pc:spChg>
-      </pc:sldChg>
-      <pc:sldChg chg="modSp add mod ord modAnim modNotesTx">
-        <pc:chgData name="JORGE GALLUD CANO" userId="aa07a950-3061-465d-9845-1f16ea714d1e" providerId="ADAL" clId="{E31950EB-08BC-4E48-96C9-D7EFC5D50408}" dt="2025-09-05T09:11:29.650" v="465" actId="6549"/>
-        <pc:sldMkLst>
-          <pc:docMk/>
-          <pc:sldMk cId="4071261284" sldId="531"/>
-        </pc:sldMkLst>
-        <pc:spChg chg="mod">
-          <ac:chgData name="JORGE GALLUD CANO" userId="aa07a950-3061-465d-9845-1f16ea714d1e" providerId="ADAL" clId="{E31950EB-08BC-4E48-96C9-D7EFC5D50408}" dt="2025-09-05T09:06:22.603" v="430" actId="404"/>
-          <ac:spMkLst>
-            <pc:docMk/>
-            <pc:sldMk cId="4071261284" sldId="531"/>
-            <ac:spMk id="2" creationId="{A4E7B4C6-D294-D62E-38BF-A001564C99A2}"/>
-          </ac:spMkLst>
-        </pc:spChg>
-        <pc:spChg chg="mod">
-          <ac:chgData name="JORGE GALLUD CANO" userId="aa07a950-3061-465d-9845-1f16ea714d1e" providerId="ADAL" clId="{E31950EB-08BC-4E48-96C9-D7EFC5D50408}" dt="2025-09-05T09:11:29.650" v="465" actId="6549"/>
-          <ac:spMkLst>
-            <pc:docMk/>
-            <pc:sldMk cId="4071261284" sldId="531"/>
-            <ac:spMk id="6" creationId="{3D1480F5-F7BC-7C10-403D-D86AC7652788}"/>
           </ac:spMkLst>
         </pc:spChg>
       </pc:sldChg>
@@ -1076,7 +241,7 @@
           <a:p>
             <a:fld id="{9356850D-52B1-405F-8CD7-E0365C566C9E}" type="datetimeFigureOut">
               <a:rPr lang="es-ES" smtClean="0"/>
-              <a:t>14/09/2025</a:t>
+              <a:t>09/09/2026</a:t>
             </a:fld>
             <a:endParaRPr lang="es-ES"/>
           </a:p>
@@ -1242,7 +407,7 @@
           <a:p>
             <a:fld id="{EA1C35A5-6E39-4CDE-A04F-1B1EEA008340}" type="datetimeFigureOut">
               <a:rPr lang="es-ES" smtClean="0"/>
-              <a:t>13/09/2025</a:t>
+              <a:t>09/09/2026</a:t>
             </a:fld>
             <a:endParaRPr lang="es-ES"/>
           </a:p>
@@ -5914,12 +5079,9 @@
             </a:pPr>
             <a:r>
               <a:rPr lang="es-ES" dirty="0" err="1"/>
-              <a:t>Exam</a:t>
-            </a:r>
-            <a:r>
-              <a:rPr lang="es-ES" dirty="0"/>
-              <a:t> (15%)</a:t>
-            </a:r>
+              <a:t>Exams</a:t>
+            </a:r>
+            <a:endParaRPr lang="es-ES" dirty="0"/>
           </a:p>
           <a:p>
             <a:pPr marL="768350" lvl="1" indent="0">
@@ -5929,28 +5091,8 @@
               <a:buNone/>
             </a:pPr>
             <a:r>
-              <a:rPr lang="es-ES" dirty="0" err="1"/>
-              <a:t>Presentations</a:t>
-            </a:r>
-            <a:r>
-              <a:rPr lang="es-ES" dirty="0"/>
-              <a:t> (15%)</a:t>
-            </a:r>
-          </a:p>
-          <a:p>
-            <a:pPr marL="768350" lvl="1" indent="0">
-              <a:lnSpc>
-                <a:spcPct val="100000"/>
-              </a:lnSpc>
-              <a:buNone/>
-            </a:pPr>
-            <a:r>
-              <a:rPr lang="es-ES" dirty="0" err="1"/>
-              <a:t>Other</a:t>
-            </a:r>
-            <a:r>
-              <a:rPr lang="es-ES" dirty="0"/>
-              <a:t> </a:t>
+              <a:rPr lang="es-ES" dirty="0"/>
+              <a:t>Other </a:t>
             </a:r>
             <a:r>
               <a:rPr lang="es-ES" dirty="0" err="1"/>
@@ -5978,7 +5120,7 @@
             </a:r>
             <a:r>
               <a:rPr lang="es-ES" dirty="0"/>
-              <a:t> (70%): 16th Jan</a:t>
+              <a:t> (70%): 19th Jan</a:t>
             </a:r>
           </a:p>
           <a:p>

</xml_diff>